<commit_message>
扇叶开场: 扇骨描边标定 0.75pt->0.15pt (接缝振幅 70.54->28.86, 目标27.8)
- v18/v19 变体扫描定标: 无描边1.18/0.10pt25.64/0.15pt28.86/0.20pt40.34/0.50pt66.52/0.75pt70.54
- 修正 deep_geometry_probe3 仪器故障: 半径按画布边界归一化(应扇子实际半径) + 全360度FFT(应只对有效90度)
- 关键教训: 亮度通道测不出金色扇骨, 必须用颜色通道(D7B97D 距离)
- 新增回归测试 test_blade_stroke_width_calibrated (已验证有防护力)
- SOP 新增 10.6 节: 仪器标定方法论 + 测量通道选择
- 全套 47/47 通过 (13+6+15+13)
</commit_message>
<xml_diff>
--- a/knowledge/Productivity/Fan_Ceiling_Showcase.pptx
+++ b/knowledge/Productivity/Fan_Ceiling_Showcase.pptx
@@ -3130,7 +3130,7 @@
               <a:gd name="adj2" fmla="val 900000"/>
             </a:avLst>
           </a:prstGeom>
-          <a:ln w="9525">
+          <a:ln w="1905">
             <a:solidFill>
               <a:srgbClr val="D7B97D"/>
             </a:solidFill>
@@ -3181,7 +3181,7 @@
               <a:gd name="adj2" fmla="val 900000"/>
             </a:avLst>
           </a:prstGeom>
-          <a:ln w="9525">
+          <a:ln w="1905">
             <a:solidFill>
               <a:srgbClr val="D7B97D"/>
             </a:solidFill>
@@ -3232,7 +3232,7 @@
               <a:gd name="adj2" fmla="val 900000"/>
             </a:avLst>
           </a:prstGeom>
-          <a:ln w="9525">
+          <a:ln w="1905">
             <a:solidFill>
               <a:srgbClr val="D7B97D"/>
             </a:solidFill>
@@ -3283,7 +3283,7 @@
               <a:gd name="adj2" fmla="val 900000"/>
             </a:avLst>
           </a:prstGeom>
-          <a:ln w="9525">
+          <a:ln w="1905">
             <a:solidFill>
               <a:srgbClr val="D7B97D"/>
             </a:solidFill>
@@ -3334,7 +3334,7 @@
               <a:gd name="adj2" fmla="val 900000"/>
             </a:avLst>
           </a:prstGeom>
-          <a:ln w="9525">
+          <a:ln w="1905">
             <a:solidFill>
               <a:srgbClr val="D7B97D"/>
             </a:solidFill>
@@ -3385,7 +3385,7 @@
               <a:gd name="adj2" fmla="val 900000"/>
             </a:avLst>
           </a:prstGeom>
-          <a:ln w="9525">
+          <a:ln w="1905">
             <a:solidFill>
               <a:srgbClr val="D7B97D"/>
             </a:solidFill>
@@ -3436,7 +3436,7 @@
               <a:gd name="adj2" fmla="val 900000"/>
             </a:avLst>
           </a:prstGeom>
-          <a:ln w="9525">
+          <a:ln w="1905">
             <a:solidFill>
               <a:srgbClr val="D7B97D"/>
             </a:solidFill>
@@ -3487,7 +3487,7 @@
               <a:gd name="adj2" fmla="val 900000"/>
             </a:avLst>
           </a:prstGeom>
-          <a:ln w="9525">
+          <a:ln w="1905">
             <a:solidFill>
               <a:srgbClr val="D7B97D"/>
             </a:solidFill>
@@ -3538,7 +3538,7 @@
               <a:gd name="adj2" fmla="val 900000"/>
             </a:avLst>
           </a:prstGeom>
-          <a:ln w="9525">
+          <a:ln w="1905">
             <a:solidFill>
               <a:srgbClr val="D7B97D"/>
             </a:solidFill>
@@ -3589,7 +3589,7 @@
               <a:gd name="adj2" fmla="val 900000"/>
             </a:avLst>
           </a:prstGeom>
-          <a:ln w="9525">
+          <a:ln w="1905">
             <a:solidFill>
               <a:srgbClr val="D7B97D"/>
             </a:solidFill>
@@ -3640,7 +3640,7 @@
               <a:gd name="adj2" fmla="val 900000"/>
             </a:avLst>
           </a:prstGeom>
-          <a:ln w="9525">
+          <a:ln w="1905">
             <a:solidFill>
               <a:srgbClr val="D7B97D"/>
             </a:solidFill>
@@ -3691,7 +3691,7 @@
               <a:gd name="adj2" fmla="val 900000"/>
             </a:avLst>
           </a:prstGeom>
-          <a:ln w="9525">
+          <a:ln w="1905">
             <a:solidFill>
               <a:srgbClr val="D7B97D"/>
             </a:solidFill>
@@ -3829,7 +3829,7 @@
               <a:gd name="adj2" fmla="val 900000"/>
             </a:avLst>
           </a:prstGeom>
-          <a:ln w="9525">
+          <a:ln w="1905">
             <a:solidFill>
               <a:srgbClr val="D7B97D"/>
             </a:solidFill>
@@ -3887,7 +3887,7 @@
               <a:gd name="adj2" fmla="val 900000"/>
             </a:avLst>
           </a:prstGeom>
-          <a:ln w="9525">
+          <a:ln w="1905">
             <a:solidFill>
               <a:srgbClr val="D7B97D"/>
             </a:solidFill>
@@ -3945,7 +3945,7 @@
               <a:gd name="adj2" fmla="val 900000"/>
             </a:avLst>
           </a:prstGeom>
-          <a:ln w="9525">
+          <a:ln w="1905">
             <a:solidFill>
               <a:srgbClr val="D7B97D"/>
             </a:solidFill>
@@ -4003,7 +4003,7 @@
               <a:gd name="adj2" fmla="val 900000"/>
             </a:avLst>
           </a:prstGeom>
-          <a:ln w="9525">
+          <a:ln w="1905">
             <a:solidFill>
               <a:srgbClr val="D7B97D"/>
             </a:solidFill>
@@ -4061,7 +4061,7 @@
               <a:gd name="adj2" fmla="val 900000"/>
             </a:avLst>
           </a:prstGeom>
-          <a:ln w="9525">
+          <a:ln w="1905">
             <a:solidFill>
               <a:srgbClr val="D7B97D"/>
             </a:solidFill>
@@ -4119,7 +4119,7 @@
               <a:gd name="adj2" fmla="val 900000"/>
             </a:avLst>
           </a:prstGeom>
-          <a:ln w="9525">
+          <a:ln w="1905">
             <a:solidFill>
               <a:srgbClr val="D7B97D"/>
             </a:solidFill>
@@ -4177,7 +4177,7 @@
               <a:gd name="adj2" fmla="val 900000"/>
             </a:avLst>
           </a:prstGeom>
-          <a:ln w="9525">
+          <a:ln w="1905">
             <a:solidFill>
               <a:srgbClr val="D7B97D"/>
             </a:solidFill>
@@ -4235,7 +4235,7 @@
               <a:gd name="adj2" fmla="val 900000"/>
             </a:avLst>
           </a:prstGeom>
-          <a:ln w="9525">
+          <a:ln w="1905">
             <a:solidFill>
               <a:srgbClr val="D7B97D"/>
             </a:solidFill>
@@ -4293,7 +4293,7 @@
               <a:gd name="adj2" fmla="val 900000"/>
             </a:avLst>
           </a:prstGeom>
-          <a:ln w="9525">
+          <a:ln w="1905">
             <a:solidFill>
               <a:srgbClr val="D7B97D"/>
             </a:solidFill>
@@ -4351,7 +4351,7 @@
               <a:gd name="adj2" fmla="val 900000"/>
             </a:avLst>
           </a:prstGeom>
-          <a:ln w="9525">
+          <a:ln w="1905">
             <a:solidFill>
               <a:srgbClr val="D7B97D"/>
             </a:solidFill>
@@ -4409,7 +4409,7 @@
               <a:gd name="adj2" fmla="val 900000"/>
             </a:avLst>
           </a:prstGeom>
-          <a:ln w="9525">
+          <a:ln w="1905">
             <a:solidFill>
               <a:srgbClr val="D7B97D"/>
             </a:solidFill>
@@ -4467,7 +4467,7 @@
               <a:gd name="adj2" fmla="val 900000"/>
             </a:avLst>
           </a:prstGeom>
-          <a:ln w="9525">
+          <a:ln w="1905">
             <a:solidFill>
               <a:srgbClr val="D7B97D"/>
             </a:solidFill>

</xml_diff>